<commit_message>
Relatorio_Atividade_2_Slides.pptx: apresentacao em slides totalmente editavel no Microsoft PowerPoint
</commit_message>
<xml_diff>
--- a/Relatorio_Atividade_2_Slides.pptx
+++ b/Relatorio_Atividade_2_Slides.pptx
@@ -5099,6 +5099,20 @@
               </a:defRPr>
             </a:pPr>
             <a:r>
+              <a:t>• LENNON, John. Imagine. In: Imagine. Produção: John Lennon, Yoko Ono, Phil Spector. Ascot Sound Studios: Apple Records, 1971. 1 faixa musical (3 min 3 s). Uso pedagógico e cultural.</a:t>
+            </a:r>
+          </a:p>
+          <a:p>
+            <a:br/>
+            <a:pPr>
+              <a:defRPr sz="950">
+                <a:solidFill>
+                  <a:srgbClr val="64748B"/>
+                </a:solidFill>
+                <a:latin typeface="Arial"/>
+              </a:defRPr>
+            </a:pPr>
+            <a:r>
               <a:t>• MDN WEB DOCS. Fetch API. Mozilla Developer Network, 2026. Disponível em: &lt;https://developer.mozilla.org/pt-BR/docs/Web/API/Fetch_API&gt;. Acesso em: 17 set. 2026.</a:t>
             </a:r>
           </a:p>
@@ -6558,7 +6572,7 @@
               </a:defRPr>
             </a:pPr>
             <a:r>
-              <a:t>A Música que Conecta Gerações</a:t>
+              <a:t>A Música que Conecta Gerações (Imagine — John Lennon, 1971)</a:t>
             </a:r>
           </a:p>
           <a:p>
@@ -6572,7 +6586,7 @@
               </a:defRPr>
             </a:pPr>
             <a:r>
-              <a:t>Nenhum projeto comunitário vive só de botões; ele vive de sentimento. O componente PlayerAudio.jsx traz a música 'Imagine' como pano de fundo de esperança.</a:t>
+              <a:t>Nenhum projeto comunitário vive só de botões; ele vive de sentimento. O componente PlayerAudio.jsx traz a clássica canção 'Imagine' de John Lennon (1971) como trilha sonora de paz e união, executada para fins pedagógicos e culturais.</a:t>
             </a:r>
           </a:p>
           <a:p>

</xml_diff>

<commit_message>
Relatorio_Atividade_2_Slides.pptx: sincronizacao da apresentacao
</commit_message>
<xml_diff>
--- a/Relatorio_Atividade_2_Slides.pptx
+++ b/Relatorio_Atividade_2_Slides.pptx
@@ -140,7 +140,7 @@
   <pc:docChgLst>
     <pc:chgData name="Amberson Rogers Lindoso da Silva" userId="1e7355cac7a206dd" providerId="LiveId" clId="{F3CFAD84-59F1-4795-A6D8-6D79CCCB1EA4}"/>
     <pc:docChg chg="undo custSel modSld">
-      <pc:chgData name="Amberson Rogers Lindoso da Silva" userId="1e7355cac7a206dd" providerId="LiveId" clId="{F3CFAD84-59F1-4795-A6D8-6D79CCCB1EA4}" dt="2026-09-17T17:32:43.060" v="145" actId="20577"/>
+      <pc:chgData name="Amberson Rogers Lindoso da Silva" userId="1e7355cac7a206dd" providerId="LiveId" clId="{F3CFAD84-59F1-4795-A6D8-6D79CCCB1EA4}" dt="2026-09-17T17:33:37.865" v="171" actId="6549"/>
       <pc:docMkLst>
         <pc:docMk/>
       </pc:docMkLst>
@@ -323,13 +323,13 @@
         </pc:spChg>
       </pc:sldChg>
       <pc:sldChg chg="modSp mod">
-        <pc:chgData name="Amberson Rogers Lindoso da Silva" userId="1e7355cac7a206dd" providerId="LiveId" clId="{F3CFAD84-59F1-4795-A6D8-6D79CCCB1EA4}" dt="2026-09-17T17:32:43.060" v="145" actId="20577"/>
+        <pc:chgData name="Amberson Rogers Lindoso da Silva" userId="1e7355cac7a206dd" providerId="LiveId" clId="{F3CFAD84-59F1-4795-A6D8-6D79CCCB1EA4}" dt="2026-09-17T17:33:37.865" v="171" actId="6549"/>
         <pc:sldMkLst>
           <pc:docMk/>
           <pc:sldMk cId="0" sldId="262"/>
         </pc:sldMkLst>
         <pc:spChg chg="mod">
-          <ac:chgData name="Amberson Rogers Lindoso da Silva" userId="1e7355cac7a206dd" providerId="LiveId" clId="{F3CFAD84-59F1-4795-A6D8-6D79CCCB1EA4}" dt="2026-09-17T17:32:43.060" v="145" actId="20577"/>
+          <ac:chgData name="Amberson Rogers Lindoso da Silva" userId="1e7355cac7a206dd" providerId="LiveId" clId="{F3CFAD84-59F1-4795-A6D8-6D79CCCB1EA4}" dt="2026-09-17T17:33:37.865" v="171" actId="6549"/>
           <ac:spMkLst>
             <pc:docMk/>
             <pc:sldMk cId="0" sldId="262"/>
@@ -14133,7 +14133,7 @@
             </a:br>
             <a:r>
               <a:rPr dirty="0"/>
-              <a:t>├── </a:t>
+              <a:t>├ </a:t>
             </a:r>
             <a:r>
               <a:rPr dirty="0" err="1"/>
@@ -14144,9 +14144,10 @@
               <a:t> (IBGE &amp; Leaflet)</a:t>
             </a:r>
             <a:br>
-              <a:rPr/>
+              <a:rPr dirty="0"/>
             </a:br>
             <a:r>
+              <a:rPr dirty="0"/>
               <a:t>├ </a:t>
             </a:r>
             <a:r>
@@ -14170,7 +14171,7 @@
             </a:br>
             <a:r>
               <a:rPr dirty="0"/>
-              <a:t>├── </a:t>
+              <a:t>├ </a:t>
             </a:r>
             <a:r>
               <a:rPr dirty="0" err="1"/>
@@ -14185,7 +14186,7 @@
             </a:br>
             <a:r>
               <a:rPr dirty="0"/>
-              <a:t>├── </a:t>
+              <a:t>├ </a:t>
             </a:r>
             <a:r>
               <a:rPr dirty="0" err="1"/>
@@ -14208,7 +14209,7 @@
             </a:br>
             <a:r>
               <a:rPr dirty="0"/>
-              <a:t>├── </a:t>
+              <a:t>├ </a:t>
             </a:r>
             <a:r>
               <a:rPr dirty="0" err="1"/>
@@ -14223,7 +14224,7 @@
             </a:br>
             <a:r>
               <a:rPr dirty="0"/>
-              <a:t>├── </a:t>
+              <a:t>├ </a:t>
             </a:r>
             <a:r>
               <a:rPr dirty="0" err="1"/>
@@ -14246,7 +14247,7 @@
             </a:br>
             <a:r>
               <a:rPr dirty="0"/>
-              <a:t>├── </a:t>
+              <a:t>├ </a:t>
             </a:r>
             <a:r>
               <a:rPr dirty="0" err="1"/>
@@ -14261,7 +14262,7 @@
             </a:br>
             <a:r>
               <a:rPr dirty="0"/>
-              <a:t>├── </a:t>
+              <a:t>├ </a:t>
             </a:r>
             <a:r>
               <a:rPr dirty="0" err="1"/>
@@ -14283,8 +14284,19 @@
               <a:rPr dirty="0"/>
             </a:br>
             <a:r>
-              <a:rPr dirty="0"/>
-              <a:t>└── </a:t>
+              <a:rPr lang="pt-BR" dirty="0"/>
+              <a:t> </a:t>
+            </a:r>
+            <a:r>
+              <a:rPr dirty="0"/>
+              <a:t>└</a:t>
+            </a:r>
+            <a:r>
+              <a:rPr lang="pt-BR"/>
+              <a:t>-</a:t>
+            </a:r>
+            <a:r>
+              <a:t> </a:t>
             </a:r>
             <a:r>
               <a:rPr dirty="0" err="1"/>

</xml_diff>